<commit_message>
commit (auto): host: Vostro7620 date: 2026-09-27 12:16:50 no. files: 2 files: M English Literature/quotetimeline.pptx, D English Literature/~$quotetimeline.pptx
</commit_message>
<xml_diff>
--- a/English Literature/quotetimeline.pptx
+++ b/English Literature/quotetimeline.pptx
@@ -104,20 +104,6 @@
       </a:defRPr>
     </a:lvl9pPr>
   </p:defaultTextStyle>
-  <p:extLst>
-    <p:ext uri="{521415D9-36F7-43E2-AB2F-B90AF26B5E84}">
-      <p14:sectionLst xmlns:p14="http://schemas.microsoft.com/office/powerpoint/2010/main">
-        <p14:section name="Default Section" id="{0488EDB4-8338-4353-877C-6AD2463F16AA}">
-          <p14:sldIdLst/>
-        </p14:section>
-        <p14:section name="Untitled Section" id="{EF9B2B25-F94E-40DD-85DA-3E35BEAA094D}">
-          <p14:sldIdLst>
-            <p14:sldId id="257"/>
-          </p14:sldIdLst>
-        </p14:section>
-      </p14:sectionLst>
-    </p:ext>
-  </p:extLst>
 </p:presentation>
 </file>
 
@@ -1026,69 +1012,69 @@
       </dgm:t>
     </dgm:pt>
     <dgm:pt modelId="{7F3D4A2D-1D3E-4684-BD05-C461A0CBBAAA}">
-      <dgm:prSet phldrT="Write a description of the significance of this event" phldr="0"/>
+      <dgm:prSet phldrT="Write a description of the significance of this event" phldr="0" custT="1"/>
       <dgm:spPr/>
       <dgm:t>
         <a:bodyPr/>
         <a:lstStyle/>
         <a:p>
           <a:r>
-            <a:rPr lang="en-GB" b="1" dirty="0"/>
+            <a:rPr lang="en-GB" sz="1000" b="1" dirty="0"/>
             <a:t>Scene 1: </a:t>
           </a:r>
           <a:r>
-            <a:rPr lang="en-GB" dirty="0"/>
+            <a:rPr lang="en-GB" sz="1000" dirty="0"/>
             <a:t>“Feather of lead”</a:t>
           </a:r>
           <a:br>
-            <a:rPr lang="en-GB" dirty="0"/>
+            <a:rPr lang="en-GB" sz="1000" dirty="0"/>
           </a:br>
           <a:r>
-            <a:rPr lang="en-GB" b="1" dirty="0"/>
+            <a:rPr lang="en-GB" sz="1000" b="1" dirty="0"/>
             <a:t>Scene 2: </a:t>
           </a:r>
           <a:r>
-            <a:rPr lang="en-GB" dirty="0"/>
+            <a:rPr lang="en-GB" sz="1000" dirty="0"/>
             <a:t>“Younger than she are happy mothers made”</a:t>
           </a:r>
           <a:br>
-            <a:rPr lang="en-GB" dirty="0"/>
+            <a:rPr lang="en-GB" sz="1000" dirty="0"/>
           </a:br>
           <a:r>
-            <a:rPr lang="en-GB" b="1" dirty="0"/>
+            <a:rPr lang="en-GB" sz="1000" b="1" dirty="0"/>
             <a:t>Scene 3: </a:t>
           </a:r>
           <a:r>
-            <a:rPr lang="en-GB" dirty="0"/>
+            <a:rPr lang="en-GB" sz="1000" dirty="0"/>
             <a:t>“</a:t>
           </a:r>
           <a:r>
-            <a:rPr lang="en-US" dirty="0"/>
+            <a:rPr lang="en-US" sz="1000" dirty="0"/>
             <a:t>I'll look to like, if looking liking move”</a:t>
           </a:r>
           <a:br>
-            <a:rPr lang="en-US" dirty="0"/>
+            <a:rPr lang="en-US" sz="1000" dirty="0"/>
           </a:br>
           <a:r>
-            <a:rPr lang="en-US" b="1" dirty="0"/>
+            <a:rPr lang="en-US" sz="1000" b="1" dirty="0"/>
             <a:t>Scene 4: </a:t>
           </a:r>
           <a:r>
-            <a:rPr lang="en-US" dirty="0"/>
+            <a:rPr lang="en-US" sz="1000" dirty="0"/>
             <a:t>(Dreams) “the children of an idle brain, begot of nothing but vain fantasy”, “my mind misgives Some consequence yet hanging in the stars.”</a:t>
           </a:r>
           <a:br>
-            <a:rPr lang="en-US" dirty="0"/>
+            <a:rPr lang="en-US" sz="1000" dirty="0"/>
           </a:br>
           <a:r>
-            <a:rPr lang="en-US" b="1" dirty="0"/>
+            <a:rPr lang="en-US" sz="1000" b="1" dirty="0"/>
             <a:t>Scene 5: </a:t>
           </a:r>
           <a:r>
-            <a:rPr lang="en-US" dirty="0"/>
+            <a:rPr lang="en-US" sz="1000" dirty="0"/>
             <a:t>“My only love sprung from my only hate!”</a:t>
           </a:r>
-          <a:endParaRPr lang="en-GB" dirty="0"/>
+          <a:endParaRPr lang="en-GB" sz="1000" dirty="0"/>
         </a:p>
       </dgm:t>
     </dgm:pt>
@@ -1154,90 +1140,90 @@
       </dgm:t>
     </dgm:pt>
     <dgm:pt modelId="{6833136E-032A-481E-9751-52F614B0DC7B}">
-      <dgm:prSet phldrT="Write a description of the significance of this event" phldr="0"/>
+      <dgm:prSet phldrT="Write a description of the significance of this event" phldr="0" custT="1"/>
       <dgm:spPr/>
       <dgm:t>
         <a:bodyPr/>
         <a:lstStyle/>
         <a:p>
           <a:r>
-            <a:rPr lang="en-GB" b="1" dirty="0"/>
+            <a:rPr lang="en-GB" sz="800" b="1" dirty="0"/>
             <a:t>Scene 1: </a:t>
           </a:r>
           <a:r>
-            <a:rPr lang="en-GB" dirty="0"/>
+            <a:rPr lang="en-GB" sz="800" dirty="0"/>
             <a:t>No good quotes in my opinion, you could have “</a:t>
           </a:r>
           <a:r>
-            <a:rPr lang="en-US" dirty="0"/>
+            <a:rPr lang="en-US" sz="800" dirty="0"/>
             <a:t>I conjure thee by Rosaline's bright eyes”</a:t>
           </a:r>
           <a:br>
-            <a:rPr lang="en-US" dirty="0"/>
+            <a:rPr lang="en-US" sz="800" dirty="0"/>
           </a:br>
           <a:r>
-            <a:rPr lang="en-US" b="1" dirty="0"/>
+            <a:rPr lang="en-US" sz="800" b="1" dirty="0"/>
             <a:t>Scene 2: </a:t>
           </a:r>
           <a:r>
-            <a:rPr lang="en-US" dirty="0"/>
+            <a:rPr lang="en-US" sz="800" dirty="0"/>
             <a:t>“O Romeo, Romeo! wherefore art thou Romeo?” (</a:t>
           </a:r>
           <a:r>
-            <a:rPr lang="en-US" b="1" dirty="0"/>
+            <a:rPr lang="en-US" sz="800" b="1" dirty="0"/>
             <a:t>Why</a:t>
           </a:r>
           <a:r>
-            <a:rPr lang="en-US" b="0" dirty="0"/>
+            <a:rPr lang="en-US" sz="800" b="0" dirty="0"/>
             <a:t> are you Romeo)</a:t>
           </a:r>
           <a:br>
-            <a:rPr lang="en-US" b="0" dirty="0"/>
+            <a:rPr lang="en-US" sz="800" b="0" dirty="0"/>
           </a:br>
           <a:r>
-            <a:rPr lang="en-US" b="1" dirty="0"/>
+            <a:rPr lang="en-US" sz="800" b="1" dirty="0"/>
             <a:t>Scene 3: </a:t>
           </a:r>
           <a:r>
-            <a:rPr lang="en-US" b="0" dirty="0"/>
+            <a:rPr lang="en-US" sz="800" b="0" dirty="0"/>
             <a:t>“Young men's love lies not truly in their hearts, but in their eyes”</a:t>
           </a:r>
           <a:br>
-            <a:rPr lang="en-US" b="0" dirty="0"/>
+            <a:rPr lang="en-US" sz="800" b="0" dirty="0"/>
           </a:br>
           <a:r>
-            <a:rPr lang="en-US" b="1" dirty="0"/>
+            <a:rPr lang="en-US" sz="800" b="1" dirty="0"/>
             <a:t>Scene 4: </a:t>
           </a:r>
           <a:r>
-            <a:rPr lang="en-US" b="0" dirty="0"/>
+            <a:rPr lang="en-US" sz="800" b="0" dirty="0"/>
             <a:t>No good quotes…</a:t>
           </a:r>
         </a:p>
         <a:p>
           <a:r>
-            <a:rPr lang="en-US" b="1" dirty="0"/>
+            <a:rPr lang="en-US" sz="800" b="1" dirty="0"/>
             <a:t>Scene 5: </a:t>
           </a:r>
           <a:r>
-            <a:rPr lang="en-US" b="0" dirty="0"/>
+            <a:rPr lang="en-US" sz="800" b="0" dirty="0"/>
             <a:t>“Then hie you hence to Friar Laurence' cell”</a:t>
           </a:r>
         </a:p>
         <a:p>
           <a:r>
-            <a:rPr lang="en-GB" b="1" dirty="0"/>
+            <a:rPr lang="en-GB" sz="800" b="1" dirty="0"/>
             <a:t>Scene 6: </a:t>
           </a:r>
           <a:r>
-            <a:rPr lang="en-GB" dirty="0"/>
+            <a:rPr lang="en-GB" sz="800" dirty="0"/>
             <a:t>"</a:t>
           </a:r>
           <a:r>
-            <a:rPr lang="en-US" dirty="0"/>
+            <a:rPr lang="en-US" sz="800" dirty="0"/>
             <a:t>These violent delights have violent ends “, “My true love is grown to such excess”</a:t>
           </a:r>
-          <a:endParaRPr lang="en-GB" dirty="0"/>
+          <a:endParaRPr lang="en-GB" sz="800" dirty="0"/>
         </a:p>
       </dgm:t>
     </dgm:pt>
@@ -1303,105 +1289,105 @@
       </dgm:t>
     </dgm:pt>
     <dgm:pt modelId="{271911FC-7FC3-4EC6-9A72-CB6A8E458690}">
-      <dgm:prSet phldrT="Write a description of the significance of this event" phldr="0"/>
+      <dgm:prSet phldrT="Write a description of the significance of this event" phldr="0" custT="1"/>
       <dgm:spPr/>
       <dgm:t>
         <a:bodyPr/>
         <a:lstStyle/>
         <a:p>
           <a:r>
-            <a:rPr lang="en-GB" b="1" dirty="0"/>
+            <a:rPr lang="en-GB" sz="800" b="1" dirty="0"/>
             <a:t>Scene 1: Turning point of the Play </a:t>
           </a:r>
           <a:r>
-            <a:rPr lang="en-GB" dirty="0"/>
+            <a:rPr lang="en-GB" sz="800" dirty="0"/>
             <a:t>“reason of my love” “</a:t>
           </a:r>
           <a:r>
-            <a:rPr lang="en-US" dirty="0"/>
+            <a:rPr lang="en-US" sz="800" dirty="0"/>
             <a:t>good Capulet,—which name I tender As dearly as my own”, </a:t>
           </a:r>
           <a:r>
-            <a:rPr lang="en-US" b="1" dirty="0"/>
+            <a:rPr lang="en-US" sz="800" b="1" dirty="0"/>
             <a:t>“A plague o' both your houses!”, </a:t>
           </a:r>
           <a:r>
-            <a:rPr lang="en-US" dirty="0"/>
+            <a:rPr lang="en-US" sz="800" dirty="0"/>
             <a:t>“ask for me tomorrow, and you shall find me a grave man.”, </a:t>
           </a:r>
           <a:r>
-            <a:rPr lang="en-US" b="1" dirty="0"/>
+            <a:rPr lang="en-US" sz="800" b="1" dirty="0"/>
             <a:t>“Either thou, or I, or both, must go with him.”</a:t>
           </a:r>
           <a:r>
-            <a:rPr lang="en-US" dirty="0"/>
+            <a:rPr lang="en-US" sz="800" dirty="0"/>
             <a:t>, “O, I am fortune's fool!”</a:t>
           </a:r>
           <a:br>
-            <a:rPr lang="en-US" dirty="0"/>
+            <a:rPr lang="en-US" sz="800" dirty="0"/>
           </a:br>
           <a:r>
-            <a:rPr lang="en-US" b="1" dirty="0"/>
+            <a:rPr lang="en-US" sz="800" b="1" dirty="0"/>
             <a:t>Scene 2: </a:t>
           </a:r>
           <a:r>
-            <a:rPr lang="en-US" dirty="0"/>
+            <a:rPr lang="en-US" sz="800" dirty="0"/>
             <a:t>“Shall I speak ill of him that is my husband?”, </a:t>
           </a:r>
           <a:br>
-            <a:rPr lang="en-US" dirty="0"/>
+            <a:rPr lang="en-US" sz="800" dirty="0"/>
           </a:br>
           <a:r>
-            <a:rPr lang="en-US" b="1" dirty="0"/>
+            <a:rPr lang="en-US" sz="800" b="1" dirty="0"/>
             <a:t>Scene 3: </a:t>
           </a:r>
           <a:r>
-            <a:rPr lang="en-US" dirty="0"/>
+            <a:rPr lang="en-US" sz="800" dirty="0"/>
             <a:t>“Ha, banishment! be merciful, say death!”, “</a:t>
           </a:r>
           <a:r>
-            <a:rPr lang="en-GB" dirty="0"/>
+            <a:rPr lang="en-GB" sz="800" dirty="0"/>
             <a:t>Thy tears are womanish”, “</a:t>
           </a:r>
           <a:r>
-            <a:rPr lang="en-US" dirty="0"/>
+            <a:rPr lang="en-US" sz="800" dirty="0"/>
             <a:t>thy wild acts denote the unreasonable fury of a beast.”</a:t>
           </a:r>
           <a:br>
-            <a:rPr lang="en-US" dirty="0"/>
+            <a:rPr lang="en-US" sz="800" dirty="0"/>
           </a:br>
           <a:r>
-            <a:rPr lang="en-US" b="1" dirty="0"/>
+            <a:rPr lang="en-US" sz="800" b="1" dirty="0"/>
             <a:t>Scene 4: </a:t>
           </a:r>
           <a:r>
-            <a:rPr lang="en-US" dirty="0"/>
+            <a:rPr lang="en-US" sz="800" dirty="0"/>
             <a:t>“These times of woe afford no time to woo.”</a:t>
           </a:r>
           <a:br>
-            <a:rPr lang="en-US" dirty="0"/>
+            <a:rPr lang="en-US" sz="800" dirty="0"/>
           </a:br>
           <a:r>
-            <a:rPr lang="en-US" b="1" dirty="0"/>
+            <a:rPr lang="en-US" sz="800" b="1" dirty="0"/>
             <a:t>Scene 5: </a:t>
           </a:r>
           <a:r>
-            <a:rPr lang="en-US" dirty="0"/>
+            <a:rPr lang="en-US" sz="800" dirty="0"/>
             <a:t>“It was the nightingale, and not the lark,”, “Hang thee, young baggage! disobedient wretch!” “my fingers itch.”</a:t>
           </a:r>
           <a:br>
-            <a:rPr lang="en-US" dirty="0"/>
+            <a:rPr lang="en-US" sz="800" dirty="0"/>
           </a:br>
           <a:br>
-            <a:rPr lang="en-US" dirty="0"/>
+            <a:rPr lang="en-US" sz="600" dirty="0"/>
           </a:br>
           <a:br>
-            <a:rPr lang="en-US" dirty="0"/>
+            <a:rPr lang="en-US" sz="600" dirty="0"/>
           </a:br>
           <a:br>
-            <a:rPr lang="en-US" dirty="0"/>
+            <a:rPr lang="en-US" sz="600" dirty="0"/>
           </a:br>
-          <a:endParaRPr lang="en-GB" dirty="0"/>
+          <a:endParaRPr lang="en-GB" sz="600" dirty="0"/>
         </a:p>
       </dgm:t>
     </dgm:pt>
@@ -1467,84 +1453,84 @@
       </dgm:t>
     </dgm:pt>
     <dgm:pt modelId="{D624312E-71E2-4243-8761-67F3D6E62E54}">
-      <dgm:prSet phldrT="Write a description of the significance of this event" phldr="0"/>
+      <dgm:prSet phldrT="Write a description of the significance of this event" phldr="0" custT="1"/>
       <dgm:spPr/>
       <dgm:t>
         <a:bodyPr/>
         <a:lstStyle/>
         <a:p>
           <a:r>
-            <a:rPr lang="en-GB" b="1" dirty="0"/>
+            <a:rPr lang="en-GB" sz="1000" b="1" dirty="0"/>
             <a:t>Scene 1: </a:t>
           </a:r>
           <a:r>
-            <a:rPr lang="en-GB" dirty="0"/>
+            <a:rPr lang="en-GB" sz="1000" dirty="0"/>
             <a:t>“</a:t>
           </a:r>
           <a:r>
-            <a:rPr lang="en-US" dirty="0"/>
+            <a:rPr lang="en-US" sz="1000" dirty="0"/>
             <a:t>And I am nothing slow to slack his haste.”, “Happily met, my lady and my wife!”, “O, bid me leap, rather than marry Paris,”, “Give me, give me! O, tell not me of fear!”</a:t>
           </a:r>
           <a:br>
-            <a:rPr lang="en-US" dirty="0"/>
+            <a:rPr lang="en-US" sz="1000" dirty="0"/>
           </a:br>
           <a:r>
-            <a:rPr lang="en-US" b="1" dirty="0"/>
+            <a:rPr lang="en-US" sz="1000" b="1" dirty="0"/>
             <a:t>Scene 2: </a:t>
           </a:r>
           <a:r>
-            <a:rPr lang="en-US" dirty="0"/>
+            <a:rPr lang="en-US" sz="1000" dirty="0"/>
             <a:t>No good quotes</a:t>
           </a:r>
           <a:br>
-            <a:rPr lang="en-US" dirty="0"/>
+            <a:rPr lang="en-US" sz="1000" dirty="0"/>
           </a:br>
           <a:r>
-            <a:rPr lang="en-US" b="1" dirty="0"/>
+            <a:rPr lang="en-US" sz="1000" b="1" dirty="0"/>
             <a:t>Scene 3: </a:t>
           </a:r>
           <a:r>
-            <a:rPr lang="en-US" dirty="0"/>
+            <a:rPr lang="en-US" sz="1000" dirty="0"/>
             <a:t>“Romeo, I drink to thee.”</a:t>
           </a:r>
           <a:br>
-            <a:rPr lang="en-US" dirty="0"/>
+            <a:rPr lang="en-US" sz="1000" dirty="0"/>
           </a:br>
           <a:r>
-            <a:rPr lang="en-US" b="1" dirty="0"/>
+            <a:rPr lang="en-US" sz="1000" b="1" dirty="0"/>
             <a:t>Scene 4: </a:t>
           </a:r>
           <a:r>
-            <a:rPr lang="en-US" dirty="0"/>
+            <a:rPr lang="en-US" sz="1000" dirty="0"/>
             <a:t>No </a:t>
           </a:r>
           <a:r>
-            <a:rPr lang="en-US" dirty="0" err="1"/>
+            <a:rPr lang="en-US" sz="1000" dirty="0" err="1"/>
             <a:t>qood</a:t>
           </a:r>
           <a:r>
-            <a:rPr lang="en-US" dirty="0"/>
+            <a:rPr lang="en-US" sz="1000" dirty="0"/>
             <a:t> quotes</a:t>
           </a:r>
           <a:br>
-            <a:rPr lang="en-US" dirty="0"/>
+            <a:rPr lang="en-US" sz="1000" dirty="0"/>
           </a:br>
           <a:r>
-            <a:rPr lang="en-US" b="1" dirty="0"/>
+            <a:rPr lang="en-US" sz="1000" b="1" dirty="0"/>
             <a:t>Scene 5: </a:t>
           </a:r>
           <a:r>
-            <a:rPr lang="en-US" dirty="0"/>
+            <a:rPr lang="en-US" sz="1000" dirty="0"/>
             <a:t>“</a:t>
           </a:r>
           <a:r>
-            <a:rPr lang="en-GB" dirty="0"/>
+            <a:rPr lang="en-GB" sz="1000" dirty="0"/>
             <a:t>O lamentable day!”</a:t>
           </a:r>
           <a:br>
-            <a:rPr lang="en-GB" dirty="0"/>
+            <a:rPr lang="en-GB" sz="1000" dirty="0"/>
           </a:br>
-          <a:endParaRPr lang="en-US" dirty="0"/>
+          <a:endParaRPr lang="en-US" sz="1000" dirty="0"/>
         </a:p>
       </dgm:t>
     </dgm:pt>
@@ -1610,79 +1596,79 @@
       </dgm:t>
     </dgm:pt>
     <dgm:pt modelId="{DB923670-3D85-4B6B-9BEA-699A6925CD39}">
-      <dgm:prSet phldrT="Write a description of the significance of this event" phldr="0"/>
+      <dgm:prSet phldrT="Write a description of the significance of this event" phldr="0" custT="1"/>
       <dgm:spPr/>
       <dgm:t>
         <a:bodyPr/>
         <a:lstStyle/>
         <a:p>
           <a:r>
-            <a:rPr lang="en-GB" b="1" dirty="0"/>
+            <a:rPr lang="en-GB" sz="850" b="1" dirty="0"/>
             <a:t>Scene 1: </a:t>
           </a:r>
           <a:r>
-            <a:rPr lang="en-GB" dirty="0"/>
+            <a:rPr lang="en-GB" sz="850" dirty="0"/>
             <a:t>“I defy you, stars!”, “</a:t>
           </a:r>
           <a:r>
-            <a:rPr lang="en-US" dirty="0"/>
+            <a:rPr lang="en-US" sz="850" dirty="0"/>
             <a:t>My poverty, but not my will, consents.”, </a:t>
           </a:r>
           <a:r>
-            <a:rPr lang="en-GB" dirty="0"/>
+            <a:rPr lang="en-GB" sz="850" dirty="0"/>
             <a:t>“Come, cordial and not poison, go with me.”</a:t>
           </a:r>
           <a:br>
-            <a:rPr lang="en-GB" dirty="0"/>
+            <a:rPr lang="en-GB" sz="850" dirty="0"/>
           </a:br>
           <a:r>
-            <a:rPr lang="en-GB" b="1" dirty="0"/>
+            <a:rPr lang="en-GB" sz="850" b="1" dirty="0"/>
             <a:t>Scene 2: </a:t>
           </a:r>
           <a:r>
-            <a:rPr lang="en-GB" dirty="0"/>
+            <a:rPr lang="en-GB" sz="850" dirty="0"/>
             <a:t>“</a:t>
           </a:r>
           <a:r>
-            <a:rPr lang="en-US" dirty="0"/>
+            <a:rPr lang="en-US" sz="850" dirty="0"/>
             <a:t>Suspecting that we both were in a house Where the infectious pestilence did reign, </a:t>
           </a:r>
           <a:r>
-            <a:rPr lang="en-US" dirty="0" err="1"/>
+            <a:rPr lang="en-US" sz="850" dirty="0" err="1"/>
             <a:t>Seal'd</a:t>
           </a:r>
           <a:r>
-            <a:rPr lang="en-US" dirty="0"/>
+            <a:rPr lang="en-US" sz="850" dirty="0"/>
             <a:t> up the doors, and would not let us forth;” = </a:t>
           </a:r>
           <a:r>
-            <a:rPr lang="en-US" b="1" dirty="0"/>
+            <a:rPr lang="en-US" sz="850" b="1" dirty="0"/>
             <a:t>Mercutio’s Malediction. </a:t>
           </a:r>
           <a:r>
-            <a:rPr lang="en-US" b="0" dirty="0"/>
+            <a:rPr lang="en-US" sz="850" b="0" dirty="0"/>
             <a:t>“</a:t>
           </a:r>
           <a:r>
-            <a:rPr lang="en-GB" b="0" dirty="0"/>
+            <a:rPr lang="en-GB" sz="850" b="0" dirty="0"/>
             <a:t>Unhappy fortune!”</a:t>
           </a:r>
           <a:br>
-            <a:rPr lang="en-GB" b="0" dirty="0"/>
+            <a:rPr lang="en-GB" sz="850" b="0" dirty="0"/>
           </a:br>
           <a:r>
-            <a:rPr lang="en-GB" b="1" dirty="0"/>
+            <a:rPr lang="en-GB" sz="850" b="1" dirty="0"/>
             <a:t>Scene 3: </a:t>
           </a:r>
           <a:r>
-            <a:rPr lang="en-GB" b="0" dirty="0"/>
+            <a:rPr lang="en-GB" sz="850" b="0" dirty="0"/>
             <a:t>“</a:t>
           </a:r>
           <a:r>
-            <a:rPr lang="en-US" b="0" dirty="0"/>
+            <a:rPr lang="en-US" sz="850" b="0" dirty="0"/>
             <a:t>O, I am slain! If thou be merciful, Open the tomb, lay me with Juliet.”, “Thus with a kiss I die”, “O happy dagger!”,  A greater power than we can contradict Hath thwarted our intents.” “If aught in this miscarried by my fault, let my old life be sacrificed”, “For never was a story of more woe, than this of Juliet and her Romeo.”</a:t>
           </a:r>
-          <a:endParaRPr lang="en-GB" dirty="0"/>
+          <a:endParaRPr lang="en-GB" sz="850" dirty="0"/>
         </a:p>
       </dgm:t>
     </dgm:pt>
@@ -2338,7 +2324,7 @@
         </a:bodyPr>
         <a:lstStyle/>
         <a:p>
-          <a:pPr marL="0" lvl="0" indent="0" algn="l" defTabSz="266700">
+          <a:pPr marL="0" lvl="0" indent="0" algn="l" defTabSz="444500">
             <a:lnSpc>
               <a:spcPct val="90000"/>
             </a:lnSpc>
@@ -2351,62 +2337,62 @@
             <a:buNone/>
           </a:pPr>
           <a:r>
-            <a:rPr lang="en-GB" sz="600" b="1" kern="1200" dirty="0"/>
+            <a:rPr lang="en-GB" sz="1000" b="1" kern="1200" dirty="0"/>
             <a:t>Scene 1: </a:t>
           </a:r>
           <a:r>
-            <a:rPr lang="en-GB" sz="600" kern="1200" dirty="0"/>
+            <a:rPr lang="en-GB" sz="1000" kern="1200" dirty="0"/>
             <a:t>“Feather of lead”</a:t>
           </a:r>
           <a:br>
-            <a:rPr lang="en-GB" sz="600" kern="1200" dirty="0"/>
+            <a:rPr lang="en-GB" sz="1000" kern="1200" dirty="0"/>
           </a:br>
           <a:r>
-            <a:rPr lang="en-GB" sz="600" b="1" kern="1200" dirty="0"/>
+            <a:rPr lang="en-GB" sz="1000" b="1" kern="1200" dirty="0"/>
             <a:t>Scene 2: </a:t>
           </a:r>
           <a:r>
-            <a:rPr lang="en-GB" sz="600" kern="1200" dirty="0"/>
+            <a:rPr lang="en-GB" sz="1000" kern="1200" dirty="0"/>
             <a:t>“Younger than she are happy mothers made”</a:t>
           </a:r>
           <a:br>
-            <a:rPr lang="en-GB" sz="600" kern="1200" dirty="0"/>
+            <a:rPr lang="en-GB" sz="1000" kern="1200" dirty="0"/>
           </a:br>
           <a:r>
-            <a:rPr lang="en-GB" sz="600" b="1" kern="1200" dirty="0"/>
+            <a:rPr lang="en-GB" sz="1000" b="1" kern="1200" dirty="0"/>
             <a:t>Scene 3: </a:t>
           </a:r>
           <a:r>
-            <a:rPr lang="en-GB" sz="600" kern="1200" dirty="0"/>
+            <a:rPr lang="en-GB" sz="1000" kern="1200" dirty="0"/>
             <a:t>“</a:t>
           </a:r>
           <a:r>
-            <a:rPr lang="en-US" sz="600" kern="1200" dirty="0"/>
+            <a:rPr lang="en-US" sz="1000" kern="1200" dirty="0"/>
             <a:t>I'll look to like, if looking liking move”</a:t>
           </a:r>
           <a:br>
-            <a:rPr lang="en-US" sz="600" kern="1200" dirty="0"/>
+            <a:rPr lang="en-US" sz="1000" kern="1200" dirty="0"/>
           </a:br>
           <a:r>
-            <a:rPr lang="en-US" sz="600" b="1" kern="1200" dirty="0"/>
+            <a:rPr lang="en-US" sz="1000" b="1" kern="1200" dirty="0"/>
             <a:t>Scene 4: </a:t>
           </a:r>
           <a:r>
-            <a:rPr lang="en-US" sz="600" kern="1200" dirty="0"/>
+            <a:rPr lang="en-US" sz="1000" kern="1200" dirty="0"/>
             <a:t>(Dreams) “the children of an idle brain, begot of nothing but vain fantasy”, “my mind misgives Some consequence yet hanging in the stars.”</a:t>
           </a:r>
           <a:br>
-            <a:rPr lang="en-US" sz="600" kern="1200" dirty="0"/>
+            <a:rPr lang="en-US" sz="1000" kern="1200" dirty="0"/>
           </a:br>
           <a:r>
-            <a:rPr lang="en-US" sz="600" b="1" kern="1200" dirty="0"/>
+            <a:rPr lang="en-US" sz="1000" b="1" kern="1200" dirty="0"/>
             <a:t>Scene 5: </a:t>
           </a:r>
           <a:r>
-            <a:rPr lang="en-US" sz="600" kern="1200" dirty="0"/>
+            <a:rPr lang="en-US" sz="1000" kern="1200" dirty="0"/>
             <a:t>“My only love sprung from my only hate!”</a:t>
           </a:r>
-          <a:endParaRPr lang="en-GB" sz="600" kern="1200" dirty="0"/>
+          <a:endParaRPr lang="en-GB" sz="1000" kern="1200" dirty="0"/>
         </a:p>
       </dsp:txBody>
       <dsp:txXfrm>
@@ -2451,7 +2437,7 @@
         </a:bodyPr>
         <a:lstStyle/>
         <a:p>
-          <a:pPr marL="0" lvl="0" indent="0" algn="l" defTabSz="355600">
+          <a:pPr marL="0" lvl="0" indent="0" algn="l" defTabSz="889000">
             <a:lnSpc>
               <a:spcPct val="90000"/>
             </a:lnSpc>
@@ -2465,7 +2451,7 @@
             <a:defRPr b="1"/>
           </a:pPr>
           <a:r>
-            <a:rPr lang="en-GB" sz="800" kern="1200" dirty="0"/>
+            <a:rPr lang="en-GB" sz="2000" kern="1200" dirty="0"/>
             <a:t>Act 1</a:t>
           </a:r>
         </a:p>
@@ -2558,7 +2544,7 @@
         </a:bodyPr>
         <a:lstStyle/>
         <a:p>
-          <a:pPr marL="0" lvl="0" indent="0" algn="l" defTabSz="266700">
+          <a:pPr marL="0" lvl="0" indent="0" algn="l" defTabSz="355600">
             <a:lnSpc>
               <a:spcPct val="90000"/>
             </a:lnSpc>
@@ -2571,61 +2557,61 @@
             <a:buNone/>
           </a:pPr>
           <a:r>
-            <a:rPr lang="en-GB" sz="600" b="1" kern="1200" dirty="0"/>
+            <a:rPr lang="en-GB" sz="800" b="1" kern="1200" dirty="0"/>
             <a:t>Scene 1: </a:t>
           </a:r>
           <a:r>
-            <a:rPr lang="en-GB" sz="600" kern="1200" dirty="0"/>
+            <a:rPr lang="en-GB" sz="800" kern="1200" dirty="0"/>
             <a:t>No good quotes in my opinion, you could have “</a:t>
           </a:r>
           <a:r>
-            <a:rPr lang="en-US" sz="600" kern="1200" dirty="0"/>
+            <a:rPr lang="en-US" sz="800" kern="1200" dirty="0"/>
             <a:t>I conjure thee by Rosaline's bright eyes”</a:t>
           </a:r>
           <a:br>
-            <a:rPr lang="en-US" sz="600" kern="1200" dirty="0"/>
+            <a:rPr lang="en-US" sz="800" kern="1200" dirty="0"/>
           </a:br>
           <a:r>
-            <a:rPr lang="en-US" sz="600" b="1" kern="1200" dirty="0"/>
+            <a:rPr lang="en-US" sz="800" b="1" kern="1200" dirty="0"/>
             <a:t>Scene 2: </a:t>
           </a:r>
           <a:r>
-            <a:rPr lang="en-US" sz="600" kern="1200" dirty="0"/>
+            <a:rPr lang="en-US" sz="800" kern="1200" dirty="0"/>
             <a:t>“O Romeo, Romeo! wherefore art thou Romeo?” (</a:t>
           </a:r>
           <a:r>
-            <a:rPr lang="en-US" sz="600" b="1" kern="1200" dirty="0"/>
+            <a:rPr lang="en-US" sz="800" b="1" kern="1200" dirty="0"/>
             <a:t>Why</a:t>
           </a:r>
           <a:r>
-            <a:rPr lang="en-US" sz="600" b="0" kern="1200" dirty="0"/>
+            <a:rPr lang="en-US" sz="800" b="0" kern="1200" dirty="0"/>
             <a:t> are you Romeo)</a:t>
           </a:r>
           <a:br>
-            <a:rPr lang="en-US" sz="600" b="0" kern="1200" dirty="0"/>
+            <a:rPr lang="en-US" sz="800" b="0" kern="1200" dirty="0"/>
           </a:br>
           <a:r>
-            <a:rPr lang="en-US" sz="600" b="1" kern="1200" dirty="0"/>
+            <a:rPr lang="en-US" sz="800" b="1" kern="1200" dirty="0"/>
             <a:t>Scene 3: </a:t>
           </a:r>
           <a:r>
-            <a:rPr lang="en-US" sz="600" b="0" kern="1200" dirty="0"/>
+            <a:rPr lang="en-US" sz="800" b="0" kern="1200" dirty="0"/>
             <a:t>“Young men's love lies not truly in their hearts, but in their eyes”</a:t>
           </a:r>
           <a:br>
-            <a:rPr lang="en-US" sz="600" b="0" kern="1200" dirty="0"/>
+            <a:rPr lang="en-US" sz="800" b="0" kern="1200" dirty="0"/>
           </a:br>
           <a:r>
-            <a:rPr lang="en-US" sz="600" b="1" kern="1200" dirty="0"/>
+            <a:rPr lang="en-US" sz="800" b="1" kern="1200" dirty="0"/>
             <a:t>Scene 4: </a:t>
           </a:r>
           <a:r>
-            <a:rPr lang="en-US" sz="600" b="0" kern="1200" dirty="0"/>
+            <a:rPr lang="en-US" sz="800" b="0" kern="1200" dirty="0"/>
             <a:t>No good quotes…</a:t>
           </a:r>
         </a:p>
         <a:p>
-          <a:pPr marL="0" lvl="0" indent="0" algn="l" defTabSz="266700">
+          <a:pPr marL="0" lvl="0" indent="0" algn="l" defTabSz="355600">
             <a:lnSpc>
               <a:spcPct val="90000"/>
             </a:lnSpc>
@@ -2638,16 +2624,16 @@
             <a:buNone/>
           </a:pPr>
           <a:r>
-            <a:rPr lang="en-US" sz="600" b="1" kern="1200" dirty="0"/>
+            <a:rPr lang="en-US" sz="800" b="1" kern="1200" dirty="0"/>
             <a:t>Scene 5: </a:t>
           </a:r>
           <a:r>
-            <a:rPr lang="en-US" sz="600" b="0" kern="1200" dirty="0"/>
+            <a:rPr lang="en-US" sz="800" b="0" kern="1200" dirty="0"/>
             <a:t>“Then hie you hence to Friar Laurence' cell”</a:t>
           </a:r>
         </a:p>
         <a:p>
-          <a:pPr marL="0" lvl="0" indent="0" algn="l" defTabSz="266700">
+          <a:pPr marL="0" lvl="0" indent="0" algn="l" defTabSz="355600">
             <a:lnSpc>
               <a:spcPct val="90000"/>
             </a:lnSpc>
@@ -2660,18 +2646,18 @@
             <a:buNone/>
           </a:pPr>
           <a:r>
-            <a:rPr lang="en-GB" sz="600" b="1" kern="1200" dirty="0"/>
+            <a:rPr lang="en-GB" sz="800" b="1" kern="1200" dirty="0"/>
             <a:t>Scene 6: </a:t>
           </a:r>
           <a:r>
-            <a:rPr lang="en-GB" sz="600" kern="1200" dirty="0"/>
+            <a:rPr lang="en-GB" sz="800" kern="1200" dirty="0"/>
             <a:t>"</a:t>
           </a:r>
           <a:r>
-            <a:rPr lang="en-US" sz="600" kern="1200" dirty="0"/>
+            <a:rPr lang="en-US" sz="800" kern="1200" dirty="0"/>
             <a:t>These violent delights have violent ends “, “My true love is grown to such excess”</a:t>
           </a:r>
-          <a:endParaRPr lang="en-GB" sz="600" kern="1200" dirty="0"/>
+          <a:endParaRPr lang="en-GB" sz="800" kern="1200" dirty="0"/>
         </a:p>
       </dsp:txBody>
       <dsp:txXfrm>
@@ -2716,7 +2702,7 @@
         </a:bodyPr>
         <a:lstStyle/>
         <a:p>
-          <a:pPr marL="0" lvl="0" indent="0" algn="l" defTabSz="355600">
+          <a:pPr marL="0" lvl="0" indent="0" algn="l" defTabSz="889000">
             <a:lnSpc>
               <a:spcPct val="90000"/>
             </a:lnSpc>
@@ -2730,7 +2716,7 @@
             <a:defRPr b="1"/>
           </a:pPr>
           <a:r>
-            <a:rPr lang="en-GB" sz="800" kern="1200" dirty="0"/>
+            <a:rPr lang="en-GB" sz="2000" kern="1200" dirty="0"/>
             <a:t>Act 2</a:t>
           </a:r>
         </a:p>
@@ -2925,7 +2911,7 @@
         </a:bodyPr>
         <a:lstStyle/>
         <a:p>
-          <a:pPr marL="0" lvl="0" indent="0" algn="l" defTabSz="266700">
+          <a:pPr marL="0" lvl="0" indent="0" algn="l" defTabSz="355600">
             <a:lnSpc>
               <a:spcPct val="90000"/>
             </a:lnSpc>
@@ -2938,87 +2924,87 @@
             <a:buNone/>
           </a:pPr>
           <a:r>
-            <a:rPr lang="en-GB" sz="600" b="1" kern="1200" dirty="0"/>
+            <a:rPr lang="en-GB" sz="800" b="1" kern="1200" dirty="0"/>
             <a:t>Scene 1: Turning point of the Play </a:t>
           </a:r>
           <a:r>
-            <a:rPr lang="en-GB" sz="600" kern="1200" dirty="0"/>
+            <a:rPr lang="en-GB" sz="800" kern="1200" dirty="0"/>
             <a:t>“reason of my love” “</a:t>
           </a:r>
           <a:r>
-            <a:rPr lang="en-US" sz="600" kern="1200" dirty="0"/>
+            <a:rPr lang="en-US" sz="800" kern="1200" dirty="0"/>
             <a:t>good Capulet,—which name I tender As dearly as my own”, </a:t>
           </a:r>
           <a:r>
-            <a:rPr lang="en-US" sz="600" b="1" kern="1200" dirty="0"/>
+            <a:rPr lang="en-US" sz="800" b="1" kern="1200" dirty="0"/>
             <a:t>“A plague o' both your houses!”, </a:t>
           </a:r>
           <a:r>
-            <a:rPr lang="en-US" sz="600" kern="1200" dirty="0"/>
+            <a:rPr lang="en-US" sz="800" kern="1200" dirty="0"/>
             <a:t>“ask for me tomorrow, and you shall find me a grave man.”, </a:t>
           </a:r>
           <a:r>
-            <a:rPr lang="en-US" sz="600" b="1" kern="1200" dirty="0"/>
+            <a:rPr lang="en-US" sz="800" b="1" kern="1200" dirty="0"/>
             <a:t>“Either thou, or I, or both, must go with him.”</a:t>
           </a:r>
           <a:r>
-            <a:rPr lang="en-US" sz="600" kern="1200" dirty="0"/>
+            <a:rPr lang="en-US" sz="800" kern="1200" dirty="0"/>
             <a:t>, “O, I am fortune's fool!”</a:t>
           </a:r>
           <a:br>
-            <a:rPr lang="en-US" sz="600" kern="1200" dirty="0"/>
+            <a:rPr lang="en-US" sz="800" kern="1200" dirty="0"/>
           </a:br>
           <a:r>
-            <a:rPr lang="en-US" sz="600" b="1" kern="1200" dirty="0"/>
+            <a:rPr lang="en-US" sz="800" b="1" kern="1200" dirty="0"/>
             <a:t>Scene 2: </a:t>
           </a:r>
           <a:r>
-            <a:rPr lang="en-US" sz="600" kern="1200" dirty="0"/>
+            <a:rPr lang="en-US" sz="800" kern="1200" dirty="0"/>
             <a:t>“Shall I speak ill of him that is my husband?”, </a:t>
           </a:r>
           <a:br>
-            <a:rPr lang="en-US" sz="600" kern="1200" dirty="0"/>
+            <a:rPr lang="en-US" sz="800" kern="1200" dirty="0"/>
           </a:br>
           <a:r>
-            <a:rPr lang="en-US" sz="600" b="1" kern="1200" dirty="0"/>
+            <a:rPr lang="en-US" sz="800" b="1" kern="1200" dirty="0"/>
             <a:t>Scene 3: </a:t>
           </a:r>
           <a:r>
-            <a:rPr lang="en-US" sz="600" kern="1200" dirty="0"/>
+            <a:rPr lang="en-US" sz="800" kern="1200" dirty="0"/>
             <a:t>“Ha, banishment! be merciful, say death!”, “</a:t>
           </a:r>
           <a:r>
-            <a:rPr lang="en-GB" sz="600" kern="1200" dirty="0"/>
+            <a:rPr lang="en-GB" sz="800" kern="1200" dirty="0"/>
             <a:t>Thy tears are womanish”, “</a:t>
           </a:r>
           <a:r>
-            <a:rPr lang="en-US" sz="600" kern="1200" dirty="0"/>
+            <a:rPr lang="en-US" sz="800" kern="1200" dirty="0"/>
             <a:t>thy wild acts denote the unreasonable fury of a beast.”</a:t>
           </a:r>
           <a:br>
-            <a:rPr lang="en-US" sz="600" kern="1200" dirty="0"/>
+            <a:rPr lang="en-US" sz="800" kern="1200" dirty="0"/>
           </a:br>
           <a:r>
-            <a:rPr lang="en-US" sz="600" b="1" kern="1200" dirty="0"/>
+            <a:rPr lang="en-US" sz="800" b="1" kern="1200" dirty="0"/>
             <a:t>Scene 4: </a:t>
           </a:r>
           <a:r>
-            <a:rPr lang="en-US" sz="600" kern="1200" dirty="0"/>
+            <a:rPr lang="en-US" sz="800" kern="1200" dirty="0"/>
             <a:t>“These times of woe afford no time to woo.”</a:t>
           </a:r>
           <a:br>
-            <a:rPr lang="en-US" sz="600" kern="1200" dirty="0"/>
+            <a:rPr lang="en-US" sz="800" kern="1200" dirty="0"/>
           </a:br>
           <a:r>
-            <a:rPr lang="en-US" sz="600" b="1" kern="1200" dirty="0"/>
+            <a:rPr lang="en-US" sz="800" b="1" kern="1200" dirty="0"/>
             <a:t>Scene 5: </a:t>
           </a:r>
           <a:r>
-            <a:rPr lang="en-US" sz="600" kern="1200" dirty="0"/>
+            <a:rPr lang="en-US" sz="800" kern="1200" dirty="0"/>
             <a:t>“It was the nightingale, and not the lark,”, “Hang thee, young baggage! disobedient wretch!” “my fingers itch.”</a:t>
           </a:r>
           <a:br>
-            <a:rPr lang="en-US" sz="600" kern="1200" dirty="0"/>
+            <a:rPr lang="en-US" sz="800" kern="1200" dirty="0"/>
           </a:br>
           <a:br>
             <a:rPr lang="en-US" sz="600" kern="1200" dirty="0"/>
@@ -3074,7 +3060,7 @@
         </a:bodyPr>
         <a:lstStyle/>
         <a:p>
-          <a:pPr marL="0" lvl="0" indent="0" algn="l" defTabSz="355600">
+          <a:pPr marL="0" lvl="0" indent="0" algn="l" defTabSz="889000">
             <a:lnSpc>
               <a:spcPct val="90000"/>
             </a:lnSpc>
@@ -3088,7 +3074,7 @@
             <a:defRPr b="1"/>
           </a:pPr>
           <a:r>
-            <a:rPr lang="en-GB" sz="800" kern="1200" dirty="0"/>
+            <a:rPr lang="en-GB" sz="2000" kern="1200" dirty="0"/>
             <a:t>Act 3</a:t>
           </a:r>
         </a:p>
@@ -3181,7 +3167,7 @@
         </a:bodyPr>
         <a:lstStyle/>
         <a:p>
-          <a:pPr marL="0" lvl="0" indent="0" algn="l" defTabSz="266700">
+          <a:pPr marL="0" lvl="0" indent="0" algn="l" defTabSz="444500">
             <a:lnSpc>
               <a:spcPct val="90000"/>
             </a:lnSpc>
@@ -3194,77 +3180,77 @@
             <a:buNone/>
           </a:pPr>
           <a:r>
-            <a:rPr lang="en-GB" sz="600" b="1" kern="1200" dirty="0"/>
+            <a:rPr lang="en-GB" sz="1000" b="1" kern="1200" dirty="0"/>
             <a:t>Scene 1: </a:t>
           </a:r>
           <a:r>
-            <a:rPr lang="en-GB" sz="600" kern="1200" dirty="0"/>
+            <a:rPr lang="en-GB" sz="1000" kern="1200" dirty="0"/>
             <a:t>“</a:t>
           </a:r>
           <a:r>
-            <a:rPr lang="en-US" sz="600" kern="1200" dirty="0"/>
+            <a:rPr lang="en-US" sz="1000" kern="1200" dirty="0"/>
             <a:t>And I am nothing slow to slack his haste.”, “Happily met, my lady and my wife!”, “O, bid me leap, rather than marry Paris,”, “Give me, give me! O, tell not me of fear!”</a:t>
           </a:r>
           <a:br>
-            <a:rPr lang="en-US" sz="600" kern="1200" dirty="0"/>
+            <a:rPr lang="en-US" sz="1000" kern="1200" dirty="0"/>
           </a:br>
           <a:r>
-            <a:rPr lang="en-US" sz="600" b="1" kern="1200" dirty="0"/>
+            <a:rPr lang="en-US" sz="1000" b="1" kern="1200" dirty="0"/>
             <a:t>Scene 2: </a:t>
           </a:r>
           <a:r>
-            <a:rPr lang="en-US" sz="600" kern="1200" dirty="0"/>
+            <a:rPr lang="en-US" sz="1000" kern="1200" dirty="0"/>
             <a:t>No good quotes</a:t>
           </a:r>
           <a:br>
-            <a:rPr lang="en-US" sz="600" kern="1200" dirty="0"/>
+            <a:rPr lang="en-US" sz="1000" kern="1200" dirty="0"/>
           </a:br>
           <a:r>
-            <a:rPr lang="en-US" sz="600" b="1" kern="1200" dirty="0"/>
+            <a:rPr lang="en-US" sz="1000" b="1" kern="1200" dirty="0"/>
             <a:t>Scene 3: </a:t>
           </a:r>
           <a:r>
-            <a:rPr lang="en-US" sz="600" kern="1200" dirty="0"/>
+            <a:rPr lang="en-US" sz="1000" kern="1200" dirty="0"/>
             <a:t>“Romeo, I drink to thee.”</a:t>
           </a:r>
           <a:br>
-            <a:rPr lang="en-US" sz="600" kern="1200" dirty="0"/>
+            <a:rPr lang="en-US" sz="1000" kern="1200" dirty="0"/>
           </a:br>
           <a:r>
-            <a:rPr lang="en-US" sz="600" b="1" kern="1200" dirty="0"/>
+            <a:rPr lang="en-US" sz="1000" b="1" kern="1200" dirty="0"/>
             <a:t>Scene 4: </a:t>
           </a:r>
           <a:r>
-            <a:rPr lang="en-US" sz="600" kern="1200" dirty="0"/>
+            <a:rPr lang="en-US" sz="1000" kern="1200" dirty="0"/>
             <a:t>No </a:t>
           </a:r>
           <a:r>
-            <a:rPr lang="en-US" sz="600" kern="1200" dirty="0" err="1"/>
+            <a:rPr lang="en-US" sz="1000" kern="1200" dirty="0" err="1"/>
             <a:t>qood</a:t>
           </a:r>
           <a:r>
-            <a:rPr lang="en-US" sz="600" kern="1200" dirty="0"/>
+            <a:rPr lang="en-US" sz="1000" kern="1200" dirty="0"/>
             <a:t> quotes</a:t>
           </a:r>
           <a:br>
-            <a:rPr lang="en-US" sz="600" kern="1200" dirty="0"/>
+            <a:rPr lang="en-US" sz="1000" kern="1200" dirty="0"/>
           </a:br>
           <a:r>
-            <a:rPr lang="en-US" sz="600" b="1" kern="1200" dirty="0"/>
+            <a:rPr lang="en-US" sz="1000" b="1" kern="1200" dirty="0"/>
             <a:t>Scene 5: </a:t>
           </a:r>
           <a:r>
-            <a:rPr lang="en-US" sz="600" kern="1200" dirty="0"/>
+            <a:rPr lang="en-US" sz="1000" kern="1200" dirty="0"/>
             <a:t>“</a:t>
           </a:r>
           <a:r>
-            <a:rPr lang="en-GB" sz="600" kern="1200" dirty="0"/>
+            <a:rPr lang="en-GB" sz="1000" kern="1200" dirty="0"/>
             <a:t>O lamentable day!”</a:t>
           </a:r>
           <a:br>
-            <a:rPr lang="en-GB" sz="600" kern="1200" dirty="0"/>
+            <a:rPr lang="en-GB" sz="1000" kern="1200" dirty="0"/>
           </a:br>
-          <a:endParaRPr lang="en-US" sz="600" kern="1200" dirty="0"/>
+          <a:endParaRPr lang="en-US" sz="1000" kern="1200" dirty="0"/>
         </a:p>
       </dsp:txBody>
       <dsp:txXfrm>
@@ -3309,7 +3295,7 @@
         </a:bodyPr>
         <a:lstStyle/>
         <a:p>
-          <a:pPr marL="0" lvl="0" indent="0" algn="l" defTabSz="355600">
+          <a:pPr marL="0" lvl="0" indent="0" algn="l" defTabSz="889000">
             <a:lnSpc>
               <a:spcPct val="90000"/>
             </a:lnSpc>
@@ -3323,7 +3309,7 @@
             <a:defRPr b="1"/>
           </a:pPr>
           <a:r>
-            <a:rPr lang="en-GB" sz="800" kern="1200" dirty="0"/>
+            <a:rPr lang="en-GB" sz="2000" kern="1200" dirty="0"/>
             <a:t>Act 4</a:t>
           </a:r>
         </a:p>
@@ -3518,7 +3504,7 @@
         </a:bodyPr>
         <a:lstStyle/>
         <a:p>
-          <a:pPr marL="0" lvl="0" indent="0" algn="l" defTabSz="266700">
+          <a:pPr marL="0" lvl="0" indent="0" algn="l" defTabSz="377825">
             <a:lnSpc>
               <a:spcPct val="90000"/>
             </a:lnSpc>
@@ -3531,72 +3517,72 @@
             <a:buNone/>
           </a:pPr>
           <a:r>
-            <a:rPr lang="en-GB" sz="600" b="1" kern="1200" dirty="0"/>
+            <a:rPr lang="en-GB" sz="850" b="1" kern="1200" dirty="0"/>
             <a:t>Scene 1: </a:t>
           </a:r>
           <a:r>
-            <a:rPr lang="en-GB" sz="600" kern="1200" dirty="0"/>
+            <a:rPr lang="en-GB" sz="850" kern="1200" dirty="0"/>
             <a:t>“I defy you, stars!”, “</a:t>
           </a:r>
           <a:r>
-            <a:rPr lang="en-US" sz="600" kern="1200" dirty="0"/>
+            <a:rPr lang="en-US" sz="850" kern="1200" dirty="0"/>
             <a:t>My poverty, but not my will, consents.”, </a:t>
           </a:r>
           <a:r>
-            <a:rPr lang="en-GB" sz="600" kern="1200" dirty="0"/>
+            <a:rPr lang="en-GB" sz="850" kern="1200" dirty="0"/>
             <a:t>“Come, cordial and not poison, go with me.”</a:t>
           </a:r>
           <a:br>
-            <a:rPr lang="en-GB" sz="600" kern="1200" dirty="0"/>
+            <a:rPr lang="en-GB" sz="850" kern="1200" dirty="0"/>
           </a:br>
           <a:r>
-            <a:rPr lang="en-GB" sz="600" b="1" kern="1200" dirty="0"/>
+            <a:rPr lang="en-GB" sz="850" b="1" kern="1200" dirty="0"/>
             <a:t>Scene 2: </a:t>
           </a:r>
           <a:r>
-            <a:rPr lang="en-GB" sz="600" kern="1200" dirty="0"/>
+            <a:rPr lang="en-GB" sz="850" kern="1200" dirty="0"/>
             <a:t>“</a:t>
           </a:r>
           <a:r>
-            <a:rPr lang="en-US" sz="600" kern="1200" dirty="0"/>
+            <a:rPr lang="en-US" sz="850" kern="1200" dirty="0"/>
             <a:t>Suspecting that we both were in a house Where the infectious pestilence did reign, </a:t>
           </a:r>
           <a:r>
-            <a:rPr lang="en-US" sz="600" kern="1200" dirty="0" err="1"/>
+            <a:rPr lang="en-US" sz="850" kern="1200" dirty="0" err="1"/>
             <a:t>Seal'd</a:t>
           </a:r>
           <a:r>
-            <a:rPr lang="en-US" sz="600" kern="1200" dirty="0"/>
+            <a:rPr lang="en-US" sz="850" kern="1200" dirty="0"/>
             <a:t> up the doors, and would not let us forth;” = </a:t>
           </a:r>
           <a:r>
-            <a:rPr lang="en-US" sz="600" b="1" kern="1200" dirty="0"/>
+            <a:rPr lang="en-US" sz="850" b="1" kern="1200" dirty="0"/>
             <a:t>Mercutio’s Malediction. </a:t>
           </a:r>
           <a:r>
-            <a:rPr lang="en-US" sz="600" b="0" kern="1200" dirty="0"/>
+            <a:rPr lang="en-US" sz="850" b="0" kern="1200" dirty="0"/>
             <a:t>“</a:t>
           </a:r>
           <a:r>
-            <a:rPr lang="en-GB" sz="600" b="0" kern="1200" dirty="0"/>
+            <a:rPr lang="en-GB" sz="850" b="0" kern="1200" dirty="0"/>
             <a:t>Unhappy fortune!”</a:t>
           </a:r>
           <a:br>
-            <a:rPr lang="en-GB" sz="600" b="0" kern="1200" dirty="0"/>
+            <a:rPr lang="en-GB" sz="850" b="0" kern="1200" dirty="0"/>
           </a:br>
           <a:r>
-            <a:rPr lang="en-GB" sz="600" b="1" kern="1200" dirty="0"/>
+            <a:rPr lang="en-GB" sz="850" b="1" kern="1200" dirty="0"/>
             <a:t>Scene 3: </a:t>
           </a:r>
           <a:r>
-            <a:rPr lang="en-GB" sz="600" b="0" kern="1200" dirty="0"/>
+            <a:rPr lang="en-GB" sz="850" b="0" kern="1200" dirty="0"/>
             <a:t>“</a:t>
           </a:r>
           <a:r>
-            <a:rPr lang="en-US" sz="600" b="0" kern="1200" dirty="0"/>
+            <a:rPr lang="en-US" sz="850" b="0" kern="1200" dirty="0"/>
             <a:t>O, I am slain! If thou be merciful, Open the tomb, lay me with Juliet.”, “Thus with a kiss I die”, “O happy dagger!”,  A greater power than we can contradict Hath thwarted our intents.” “If aught in this miscarried by my fault, let my old life be sacrificed”, “For never was a story of more woe, than this of Juliet and her Romeo.”</a:t>
           </a:r>
-          <a:endParaRPr lang="en-GB" sz="600" kern="1200" dirty="0"/>
+          <a:endParaRPr lang="en-GB" sz="850" kern="1200" dirty="0"/>
         </a:p>
       </dsp:txBody>
       <dsp:txXfrm>
@@ -3641,7 +3627,7 @@
         </a:bodyPr>
         <a:lstStyle/>
         <a:p>
-          <a:pPr marL="0" lvl="0" indent="0" algn="l" defTabSz="355600">
+          <a:pPr marL="0" lvl="0" indent="0" algn="l" defTabSz="889000">
             <a:lnSpc>
               <a:spcPct val="90000"/>
             </a:lnSpc>
@@ -3655,7 +3641,7 @@
             <a:defRPr b="1"/>
           </a:pPr>
           <a:r>
-            <a:rPr lang="en-GB" sz="800" kern="1200" dirty="0"/>
+            <a:rPr lang="en-GB" sz="2000" kern="1200" dirty="0"/>
             <a:t>Act 5</a:t>
           </a:r>
         </a:p>
@@ -9134,7 +9120,7 @@
           <p:nvPr>
             <p:extLst>
               <p:ext uri="{D42A27DB-BD31-4B8C-83A1-F6EECF244321}">
-                <p14:modId xmlns:p14="http://schemas.microsoft.com/office/powerpoint/2010/main" val="3977377915"/>
+                <p14:modId xmlns:p14="http://schemas.microsoft.com/office/powerpoint/2010/main" val="959880815"/>
               </p:ext>
             </p:extLst>
           </p:nvPr>

</xml_diff>